<commit_message>
updated text on target framework slide
</commit_message>
<xml_diff>
--- a/2026/OpenSourceModulesInCSharp/PSCONFEU26_EmanuelPalm_OpenSourceModulesInCSharp.pptx
+++ b/2026/OpenSourceModulesInCSharp/PSCONFEU26_EmanuelPalm_OpenSourceModulesInCSharp.pptx
@@ -12591,15 +12591,17 @@
           </a:xfrm>
         </p:spPr>
         <p:txBody>
-          <a:bodyPr/>
+          <a:bodyPr>
+            <a:normAutofit/>
+          </a:bodyPr>
           <a:lstStyle/>
           <a:p>
             <a:pPr marL="0" indent="0">
               <a:buNone/>
             </a:pPr>
             <a:r>
-              <a:rPr lang="en-US" dirty="0"/>
-              <a:t>Unless you need new .NET APIs</a:t>
+              <a:rPr lang="en-US" sz="3200" dirty="0"/>
+              <a:t>Unless you need new .NET APIs or your dependencies do</a:t>
             </a:r>
           </a:p>
         </p:txBody>

</xml_diff>

<commit_message>
write-object on slide example
</commit_message>
<xml_diff>
--- a/2026/OpenSourceModulesInCSharp/PSCONFEU26_EmanuelPalm_OpenSourceModulesInCSharp.pptx
+++ b/2026/OpenSourceModulesInCSharp/PSCONFEU26_EmanuelPalm_OpenSourceModulesInCSharp.pptx
@@ -278,7 +278,7 @@
           <a:p>
             <a:fld id="{69440670-43D7-400A-ABC5-B69E064DBB37}" type="datetimeFigureOut">
               <a:rPr lang="en-GB" smtClean="0"/>
-              <a:t>14/05/2026</a:t>
+              <a:t>02/06/2026</a:t>
             </a:fld>
             <a:endParaRPr lang="en-GB"/>
           </a:p>
@@ -537,7 +537,7 @@
           <a:p>
             <a:fld id="{611B03A4-75C9-4E3D-9183-2102CA9AEC33}" type="datetimeFigureOut">
               <a:rPr lang="en-GB" smtClean="0"/>
-              <a:t>14/05/2026</a:t>
+              <a:t>02/06/2026</a:t>
             </a:fld>
             <a:endParaRPr lang="en-GB"/>
           </a:p>
@@ -22045,39 +22045,26 @@
             </a:r>
           </a:p>
           <a:p>
-            <a:pPr marL="0" marR="0" lvl="0" indent="0" algn="l" defTabSz="914400" rtl="0" eaLnBrk="1" fontAlgn="auto" latinLnBrk="0" hangingPunct="1">
-              <a:lnSpc>
-                <a:spcPct val="100000"/>
-              </a:lnSpc>
-              <a:spcBef>
-                <a:spcPts val="0"/>
-              </a:spcBef>
-              <a:spcAft>
-                <a:spcPts val="0"/>
-              </a:spcAft>
-              <a:buClrTx/>
-              <a:buSzTx/>
-              <a:buFontTx/>
-              <a:buNone/>
-              <a:tabLst/>
+            <a:pPr lvl="0">
               <a:defRPr/>
             </a:pPr>
             <a:r>
-              <a:rPr kumimoji="0" lang="en-US" sz="1800" b="0" i="0" u="none" strike="noStrike" kern="1200" cap="none" spc="0" normalizeH="0" baseline="0" noProof="0" dirty="0">
-                <a:ln>
-                  <a:noFill/>
-                </a:ln>
+              <a:rPr lang="en-US" dirty="0">
                 <a:solidFill>
                   <a:srgbClr val="CCCCCC"/>
                 </a:solidFill>
-                <a:effectLst/>
-                <a:uLnTx/>
-                <a:uFillTx/>
-                <a:latin typeface="CaskaydiaCove NF" panose="02000009000000000000" pitchFamily="50" charset="0"/>
-                <a:ea typeface="+mn-ea"/>
-                <a:cs typeface="+mn-cs"/>
+                <a:latin typeface="CaskaydiaCove NF" panose="02000009000000000000" pitchFamily="50" charset="0"/>
               </a:rPr>
               <a:t>    </a:t>
+            </a:r>
+            <a:r>
+              <a:rPr lang="en-US" dirty="0">
+                <a:solidFill>
+                  <a:srgbClr val="DCDCAA"/>
+                </a:solidFill>
+                <a:latin typeface="CaskaydiaCove NF" panose="02000009000000000000" pitchFamily="50" charset="0"/>
+              </a:rPr>
+              <a:t>Write-Object </a:t>
             </a:r>
             <a:r>
               <a:rPr kumimoji="0" lang="en-US" sz="1800" b="0" i="0" u="none" strike="noStrike" kern="1200" cap="none" spc="0" normalizeH="0" baseline="0" noProof="0" dirty="0">
@@ -30502,6 +30489,15 @@
 </file>
 
 <file path=customXml/item1.xml><?xml version="1.0" encoding="utf-8"?>
+<?mso-contentType ?>
+<FormTemplates xmlns="http://schemas.microsoft.com/sharepoint/v3/contenttype/forms">
+  <Display>DocumentLibraryForm</Display>
+  <Edit>DocumentLibraryForm</Edit>
+  <New>DocumentLibraryForm</New>
+</FormTemplates>
+</file>
+
+<file path=customXml/item2.xml><?xml version="1.0" encoding="utf-8"?>
 <p:properties xmlns:p="http://schemas.microsoft.com/office/2006/metadata/properties" xmlns:xsi="http://www.w3.org/2001/XMLSchema-instance" xmlns:pc="http://schemas.microsoft.com/office/infopath/2007/PartnerControls">
   <documentManagement>
     <lcf76f155ced4ddcb4097134ff3c332f xmlns="abdc9a1f-962e-4235-838d-61f9c438f4db">
@@ -30510,15 +30506,6 @@
     <TaxCatchAll xmlns="de47e97d-64fd-4aef-b10e-fd7d6cfcfcf4" xsi:nil="true"/>
   </documentManagement>
 </p:properties>
-</file>
-
-<file path=customXml/item2.xml><?xml version="1.0" encoding="utf-8"?>
-<?mso-contentType ?>
-<FormTemplates xmlns="http://schemas.microsoft.com/sharepoint/v3/contenttype/forms">
-  <Display>DocumentLibraryForm</Display>
-  <Edit>DocumentLibraryForm</Edit>
-  <New>DocumentLibraryForm</New>
-</FormTemplates>
 </file>
 
 <file path=customXml/item3.xml><?xml version="1.0" encoding="utf-8"?>
@@ -30729,6 +30716,14 @@
 </file>
 
 <file path=customXml/itemProps1.xml><?xml version="1.0" encoding="utf-8"?>
+<ds:datastoreItem xmlns:ds="http://schemas.openxmlformats.org/officeDocument/2006/customXml" ds:itemID="{57D9B22B-F436-4FE5-B6C0-65AB2260F593}">
+  <ds:schemaRefs>
+    <ds:schemaRef ds:uri="http://schemas.microsoft.com/sharepoint/v3/contenttype/forms"/>
+  </ds:schemaRefs>
+</ds:datastoreItem>
+</file>
+
+<file path=customXml/itemProps2.xml><?xml version="1.0" encoding="utf-8"?>
 <ds:datastoreItem xmlns:ds="http://schemas.openxmlformats.org/officeDocument/2006/customXml" ds:itemID="{AA9C06E3-346E-408E-B352-32E922A070CE}">
   <ds:schemaRefs>
     <ds:schemaRef ds:uri="2347cc20-e10c-452d-848a-c18e83138525"/>
@@ -30739,14 +30734,6 @@
     <ds:schemaRef ds:uri="de47e97d-64fd-4aef-b10e-fd7d6cfcfcf4"/>
     <ds:schemaRef ds:uri="http://schemas.microsoft.com/office/2006/metadata/properties"/>
     <ds:schemaRef ds:uri="http://schemas.microsoft.com/office/infopath/2007/PartnerControls"/>
-  </ds:schemaRefs>
-</ds:datastoreItem>
-</file>
-
-<file path=customXml/itemProps2.xml><?xml version="1.0" encoding="utf-8"?>
-<ds:datastoreItem xmlns:ds="http://schemas.openxmlformats.org/officeDocument/2006/customXml" ds:itemID="{57D9B22B-F436-4FE5-B6C0-65AB2260F593}">
-  <ds:schemaRefs>
-    <ds:schemaRef ds:uri="http://schemas.microsoft.com/sharepoint/v3/contenttype/forms"/>
   </ds:schemaRefs>
 </ds:datastoreItem>
 </file>

</xml_diff>